<commit_message>
Add per-system individual access with a ticket-style lab map
CS Labs 1-6 have 70 systems, AR/VR Lab 40 and Mac Lab 40. Individual
access in these labs books one numbered system; group bookings still
reserve the whole lab, and each blocks the other.

- Store systems per room and system_number per booking (additive,
  one-time migration; coordinators can edit counts, not below a
  system with an active booking).
- Seat-level conflict check at creation and approval.
- GET /rooms/:id/systems returns free/booked/yours/blocked without
  revealing who booked; room finder and availability report systems.
- Ticket-style system map in the booking form, a View systems dialog,
  hatched partly-booked timeline slots, and system numbers in lists
  and CSV.
- Lab capacity in Save My Practical follows the system count.
- Add tests (48 total), docs and demo data; refresh the presentation.

Co-Authored-By: Claude Sonnet 5.5 <noreply@anthropic.com>
</commit_message>
<xml_diff>
--- a/docs/SRM-LabReserve.pptx
+++ b/docs/SRM-LabReserve.pptx
@@ -507,7 +507,7 @@
           <a:lstStyle/>
           <a:p>
             <a:r>
-              <a:t>Open with the one-line pitch: SRM LabReserve lets students and researchers request lab rooms and instruments, and lets lab coordinators approve them, with every decision recorded. The campus inventory has 22 rooms. The 37 passing tests are on the last slides.</a:t>
+              <a:t>Open with the one-line pitch: SRM LabReserve lets students and researchers request lab rooms and instruments, and lets lab coordinators approve them, with every decision recorded. The campus inventory has 22 rooms. The 48 passing tests are on the last slides.</a:t>
             </a:r>
           </a:p>
         </p:txBody>
@@ -647,7 +647,7 @@
           <a:lstStyle/>
           <a:p>
             <a:r>
-              <a:t>Walk through the six areas. Save My Practical is the distinctive one: a teacher enters the activity, class size and time, and gets ranked alternatives with reasons. Its lab capacities are illustrative demo data, not verified SRM specifications. Student counts are requested headcounts, not attendance.</a:t>
+              <a:t>Walk through the six areas. In CS, AR/VR and Mac labs an individual student books one numbered system on a ticket-style map, while a group booking still takes the whole lab. Save My Practical is the distinctive one: a teacher enters the activity, class size and time, and gets ranked alternatives with reasons. Its lab capacities are illustrative demo data, not verified SRM specifications. Student counts are requested headcounts, not attendance.</a:t>
             </a:r>
           </a:p>
         </p:txBody>
@@ -787,7 +787,7 @@
           <a:lstStyle/>
           <a:p>
             <a:r>
-              <a:t>Security is enforced on the server: hiding a button is not the protection. The 37 tests use real HTTP requests, separate student and coordinator logins, and a temporary SQLite database. One test injects conflicting legacy data on purpose to prove approval rechecks conflicts.</a:t>
+              <a:t>Security is enforced on the server: hiding a button is not the protection. The 48 tests use real HTTP requests, separate student and coordinator logins, and a temporary SQLite database. One test injects conflicting legacy data on purpose to prove approval rechecks conflicts.</a:t>
             </a:r>
           </a:p>
         </p:txBody>
@@ -4284,7 +4284,7 @@
                 </a:solidFill>
                 <a:latin typeface="Cambria"/>
               </a:rPr>
-              <a:t>37</a:t>
+              <a:t>48</a:t>
             </a:r>
           </a:p>
         </p:txBody>
@@ -5102,7 +5102,7 @@
                 </a:solidFill>
                 <a:latin typeface="Cambria"/>
               </a:rPr>
-              <a:t>Rooms and equipment</a:t>
+              <a:t>Rooms and systems</a:t>
             </a:r>
           </a:p>
           <a:p>
@@ -5114,7 +5114,7 @@
                 </a:solidFill>
                 <a:latin typeface="Calibri"/>
               </a:rPr>
-              <a:t>22 campus labs plus demo instruments, with a required reason</a:t>
+              <a:t>Whole labs, or one numbered system in a 70-system lab</a:t>
             </a:r>
           </a:p>
         </p:txBody>
@@ -5212,7 +5212,7 @@
                 </a:solidFill>
                 <a:latin typeface="Calibri"/>
               </a:rPr>
-              <a:t>Pick a time and see rooms with no overlapping booking</a:t>
+              <a:t>Pick a time and see free rooms and free systems</a:t>
             </a:r>
           </a:p>
         </p:txBody>
@@ -7325,7 +7325,7 @@
                 </a:solidFill>
                 <a:latin typeface="Cambria"/>
               </a:rPr>
-              <a:t>37</a:t>
+              <a:t>48</a:t>
             </a:r>
           </a:p>
         </p:txBody>
@@ -7403,7 +7403,7 @@
                 </a:solidFill>
                 <a:latin typeface="Calibri"/>
               </a:rPr>
-              <a:t>Overlaps, adjacency, simultaneous requests</a:t>
+              <a:t>Room and per-system overlaps, adjacency</a:t>
             </a:r>
           </a:p>
           <a:p>

</xml_diff>